<commit_message>
docs(submission): IR-Deck.pptx 작업 트리 수정본 커밋
2026-09-28 무렵부터 작업 트리에만 있던 수정본(114,115 → 127,031 B)을 커밋한다.
2026-10-02 사용자 승인(「추천대로」). 이전 판도 이미 이 저장소에 공개돼 있다.

Co-Authored-By: Claude Opus 5.5 <noreply@anthropic.com>
</commit_message>
<xml_diff>
--- a/docs/submission/IR-Deck.pptx
+++ b/docs/submission/IR-Deck.pptx
@@ -2700,36 +2700,76 @@
         <p:spPr>
           <a:xfrm>
             <a:off x="1143000" y="3911352"/>
-            <a:ext cx="12571250" cy="2013049"/>
-          </a:xfrm>
-          <a:prstGeom prst="rect">
-            <a:avLst/>
-          </a:prstGeom>
-          <a:noFill/>
-          <a:ln/>
-        </p:spPr>
-        <p:txBody>
-          <a:bodyPr wrap="square" lIns="25400" tIns="25400" rIns="25400" bIns="25400" rtlCol="0" anchor="t">
-            <a:normAutofit/>
-          </a:bodyPr>
-          <a:lstStyle/>
-          <a:p>
-            <a:pPr marL="0" indent="0" algn="l">
-              <a:lnSpc>
-                <a:spcPct val="76235"/>
-              </a:lnSpc>
+            <a:ext cx="12701789" cy="2013049"/>
+          </a:xfrm>
+          <a:prstGeom prst="rect">
+            <a:avLst/>
+          </a:prstGeom>
+          <a:noFill/>
+          <a:ln/>
+        </p:spPr>
+        <p:txBody>
+          <a:bodyPr wrap="square" lIns="25400" tIns="25400" rIns="25400" bIns="25400" rtlCol="0" anchor="t">
+            <a:normAutofit fontScale="92500" lnSpcReduction="10000"/>
+          </a:bodyPr>
+          <a:lstStyle/>
+          <a:p>
+            <a:pPr marL="0" indent="0" algn="l">
               <a:buNone/>
             </a:pPr>
             <a:r>
               <a:rPr lang="en-US" sz="7200" b="1" kern="0" spc="-144" dirty="0">
                 <a:solidFill>
+                  <a:srgbClr val="FF6F18"/>
+                </a:solidFill>
+                <a:latin typeface="Arial" pitchFamily="34" charset="0"/>
+                <a:ea typeface="Arial" pitchFamily="34" charset="-122"/>
+                <a:cs typeface="Arial" pitchFamily="34" charset="-120"/>
+              </a:rPr>
+              <a:t>번역</a:t>
+            </a:r>
+            <a:r>
+              <a:rPr lang="en-US" sz="7200" b="1" kern="0" spc="-144" dirty="0">
+                <a:solidFill>
                   <a:srgbClr val="201E1D"/>
                 </a:solidFill>
                 <a:latin typeface="Arial" pitchFamily="34" charset="0"/>
                 <a:ea typeface="Arial" pitchFamily="34" charset="-122"/>
                 <a:cs typeface="Arial" pitchFamily="34" charset="-120"/>
               </a:rPr>
-              <a:t>번역은 이미 잘 됩니다. 우리는 그다음을 </a:t>
+              <a:t>은 이미 잘 됩니다. </a:t>
+            </a:r>
+            <a:br>
+              <a:rPr lang="en-US" sz="7200" b="1" kern="0" spc="-144" dirty="0">
+                <a:solidFill>
+                  <a:srgbClr val="201E1D"/>
+                </a:solidFill>
+                <a:latin typeface="Arial" pitchFamily="34" charset="0"/>
+                <a:ea typeface="Arial" pitchFamily="34" charset="-122"/>
+                <a:cs typeface="Arial" pitchFamily="34" charset="-120"/>
+              </a:rPr>
+            </a:br>
+            <a:r>
+              <a:rPr lang="en-US" sz="7200" b="1" kern="0" spc="-144" dirty="0" err="1">
+                <a:solidFill>
+                  <a:srgbClr val="201E1D"/>
+                </a:solidFill>
+                <a:latin typeface="Arial" pitchFamily="34" charset="0"/>
+                <a:ea typeface="Arial" pitchFamily="34" charset="-122"/>
+                <a:cs typeface="Arial" pitchFamily="34" charset="-120"/>
+              </a:rPr>
+              <a:t>우리는</a:t>
+            </a:r>
+            <a:r>
+              <a:rPr lang="en-US" sz="7200" b="1" kern="0" spc="-144" dirty="0">
+                <a:solidFill>
+                  <a:srgbClr val="201E1D"/>
+                </a:solidFill>
+                <a:latin typeface="Arial" pitchFamily="34" charset="0"/>
+                <a:ea typeface="Arial" pitchFamily="34" charset="-122"/>
+                <a:cs typeface="Arial" pitchFamily="34" charset="-120"/>
+              </a:rPr>
+              <a:t> 그다음을 </a:t>
             </a:r>
             <a:r>
               <a:rPr lang="en-US" sz="7200" b="1" kern="0" spc="-144" dirty="0">
@@ -3516,11 +3556,9 @@
               <a:buNone/>
             </a:pPr>
             <a:r>
-              <a:rPr lang="en-US" sz="2100" dirty="0">
-                <a:solidFill>
-                  <a:srgbClr val="201E1D">
-                    <a:alpha val="60000"/>
-                  </a:srgbClr>
+              <a:rPr lang="en-US" sz="2100" b="1" dirty="0">
+                <a:solidFill>
+                  <a:srgbClr val="009B64"/>
                 </a:solidFill>
                 <a:latin typeface="Arial" pitchFamily="34" charset="0"/>
                 <a:ea typeface="Arial" pitchFamily="34" charset="-122"/>
@@ -3528,7 +3566,11 @@
               </a:rPr>
               <a:t>두 번째 줄은 실측이다. 「기획서」를 서로 다른 번역기가 product spec · project plan으로 옮겼다 — 톤이 아니라 무엇을 하라는지가 바뀌었다.</a:t>
             </a:r>
-            <a:endParaRPr lang="en-US" sz="2100" dirty="0"/>
+            <a:endParaRPr lang="en-US" sz="2100" b="1" dirty="0">
+              <a:solidFill>
+                <a:srgbClr val="009B64"/>
+              </a:solidFill>
+            </a:endParaRPr>
           </a:p>
         </p:txBody>
       </p:sp>

</xml_diff>